<commit_message>
update to slidess tetsing
</commit_message>
<xml_diff>
--- a/slides/organization.pptx
+++ b/slides/organization.pptx
@@ -280,7 +280,7 @@
               <a:pPr>
                 <a:defRPr/>
               </a:pPr>
-              <a:t>21-04-2025</a:t>
+              <a:t>10-04-2026</a:t>
             </a:fld>
             <a:endParaRPr lang="en-US"/>
           </a:p>
@@ -1610,7 +1610,7 @@
               <a:pPr>
                 <a:defRPr/>
               </a:pPr>
-              <a:t>21-04-2025</a:t>
+              <a:t>10-04-2026</a:t>
             </a:fld>
             <a:endParaRPr lang="en-US"/>
           </a:p>
@@ -1800,7 +1800,7 @@
               <a:pPr>
                 <a:defRPr/>
               </a:pPr>
-              <a:t>21-04-2025</a:t>
+              <a:t>10-04-2026</a:t>
             </a:fld>
             <a:endParaRPr lang="en-US"/>
           </a:p>
@@ -2000,7 +2000,7 @@
               <a:pPr>
                 <a:defRPr/>
               </a:pPr>
-              <a:t>21-04-2025</a:t>
+              <a:t>10-04-2026</a:t>
             </a:fld>
             <a:endParaRPr lang="en-US"/>
           </a:p>
@@ -2196,7 +2196,7 @@
               <a:pPr>
                 <a:defRPr/>
               </a:pPr>
-              <a:t>21-04-2025</a:t>
+              <a:t>10-04-2026</a:t>
             </a:fld>
             <a:endParaRPr lang="en-US"/>
           </a:p>
@@ -2463,7 +2463,7 @@
               <a:pPr>
                 <a:defRPr/>
               </a:pPr>
-              <a:t>21-04-2025</a:t>
+              <a:t>10-04-2026</a:t>
             </a:fld>
             <a:endParaRPr lang="en-US"/>
           </a:p>
@@ -2770,7 +2770,7 @@
               <a:pPr>
                 <a:defRPr/>
               </a:pPr>
-              <a:t>21-04-2025</a:t>
+              <a:t>10-04-2026</a:t>
             </a:fld>
             <a:endParaRPr lang="en-US"/>
           </a:p>
@@ -3211,7 +3211,7 @@
               <a:pPr>
                 <a:defRPr/>
               </a:pPr>
-              <a:t>21-04-2025</a:t>
+              <a:t>10-04-2026</a:t>
             </a:fld>
             <a:endParaRPr lang="en-US"/>
           </a:p>
@@ -3350,7 +3350,7 @@
               <a:pPr>
                 <a:defRPr/>
               </a:pPr>
-              <a:t>21-04-2025</a:t>
+              <a:t>10-04-2026</a:t>
             </a:fld>
             <a:endParaRPr lang="en-US"/>
           </a:p>
@@ -3467,7 +3467,7 @@
               <a:pPr>
                 <a:defRPr/>
               </a:pPr>
-              <a:t>21-04-2025</a:t>
+              <a:t>10-04-2026</a:t>
             </a:fld>
             <a:endParaRPr lang="en-US"/>
           </a:p>
@@ -3764,7 +3764,7 @@
               <a:pPr>
                 <a:defRPr/>
               </a:pPr>
-              <a:t>21-04-2025</a:t>
+              <a:t>10-04-2026</a:t>
             </a:fld>
             <a:endParaRPr lang="en-US"/>
           </a:p>
@@ -4041,7 +4041,7 @@
               <a:pPr>
                 <a:defRPr/>
               </a:pPr>
-              <a:t>21-04-2025</a:t>
+              <a:t>10-04-2026</a:t>
             </a:fld>
             <a:endParaRPr lang="en-US"/>
           </a:p>
@@ -4297,7 +4297,7 @@
               <a:pPr>
                 <a:defRPr/>
               </a:pPr>
-              <a:t>21-04-2025</a:t>
+              <a:t>10-04-2026</a:t>
             </a:fld>
             <a:endParaRPr lang="en-US"/>
           </a:p>
@@ -4896,7 +4896,7 @@
             </a:pPr>
             <a:r>
               <a:rPr lang="en-US" dirty="0"/>
-              <a:t>2024/25</a:t>
+              <a:t>2025/26</a:t>
             </a:r>
           </a:p>
           <a:p>
@@ -4907,24 +4907,12 @@
               <a:defRPr/>
             </a:pPr>
             <a:r>
-              <a:rPr lang="en-US" sz="2600" dirty="0" err="1"/>
-              <a:t>Wishnu</a:t>
-            </a:r>
-            <a:r>
               <a:rPr lang="en-US" sz="2600" dirty="0"/>
-              <a:t> </a:t>
-            </a:r>
-            <a:r>
-              <a:rPr lang="en-US" sz="2600" dirty="0" err="1"/>
-              <a:t>Prasetya</a:t>
-            </a:r>
-            <a:r>
-              <a:rPr lang="en-US" sz="2600" dirty="0"/>
-              <a:t> </a:t>
+              <a:t>Wishnu Prasetya </a:t>
             </a:r>
             <a:r>
               <a:rPr lang="en-US" sz="2800" dirty="0"/>
-              <a:t>&amp; Gabriele Keller</a:t>
+              <a:t>&amp; Paige North</a:t>
             </a:r>
             <a:endParaRPr lang="en-US" sz="2600" dirty="0"/>
           </a:p>
@@ -5012,7 +5000,22 @@
             <a:pPr eaLnBrk="1" hangingPunct="1"/>
             <a:r>
               <a:rPr lang="en-US" sz="2800" dirty="0"/>
-              <a:t>Software testing homework (3x).</a:t>
+              <a:t>Software testing </a:t>
+            </a:r>
+            <a:r>
+              <a:rPr lang="en-US" sz="2800" dirty="0" err="1"/>
+              <a:t>Quizz</a:t>
+            </a:r>
+            <a:r>
+              <a:rPr lang="en-US" sz="2800" dirty="0"/>
+              <a:t> (3x): you can redo them as many times as you want, BUT each has a closing date.</a:t>
+            </a:r>
+          </a:p>
+          <a:p>
+            <a:pPr eaLnBrk="1" hangingPunct="1"/>
+            <a:r>
+              <a:rPr lang="en-US" sz="2800" dirty="0"/>
+              <a:t>Writing formal specifications (3x): via MS-Team.</a:t>
             </a:r>
           </a:p>
           <a:p>
@@ -5162,11 +5165,11 @@
             </a:r>
             <a:r>
               <a:rPr lang="en-US" sz="2000" b="1" dirty="0"/>
-              <a:t>9 components</a:t>
+              <a:t>12 components</a:t>
             </a:r>
             <a:r>
               <a:rPr lang="en-US" sz="2000" dirty="0"/>
-              <a:t>: testing homework (3), </a:t>
+              <a:t>: quizzes (3), formal specifications (3), </a:t>
             </a:r>
             <a:r>
               <a:rPr lang="en-US" sz="2000" dirty="0">
@@ -5298,7 +5301,7 @@
             </a:r>
             <a:r>
               <a:rPr lang="en-US" sz="2000" dirty="0"/>
-              <a:t>  =   0.05 * </a:t>
+              <a:t>  =   0.025 * </a:t>
             </a:r>
             <a:r>
               <a:rPr lang="en-US" sz="2000" dirty="0">
@@ -5308,14 +5311,14 @@
                   </a:schemeClr>
                 </a:solidFill>
               </a:rPr>
-              <a:t>testing homework</a:t>
+              <a:t>formal specifications</a:t>
             </a:r>
             <a:br>
               <a:rPr lang="en-US" sz="2000" dirty="0"/>
             </a:br>
             <a:r>
               <a:rPr lang="en-US" sz="2000" dirty="0"/>
-              <a:t>           + 0.2   * </a:t>
+              <a:t>           + 0.225 * </a:t>
             </a:r>
             <a:r>
               <a:rPr lang="en-US" sz="2000" dirty="0">
@@ -5546,84 +5549,24 @@
           <a:p>
             <a:r>
               <a:rPr lang="en-US" sz="2400" dirty="0"/>
-              <a:t>Using AI like </a:t>
-            </a:r>
-            <a:r>
-              <a:rPr lang="en-US" sz="2400" dirty="0" err="1"/>
-              <a:t>ChatGPT</a:t>
-            </a:r>
+              <a:t>is not allowed! This includes for writing the code for the STV project.</a:t>
+            </a:r>
+          </a:p>
+          <a:p>
             <a:r>
               <a:rPr lang="en-US" sz="2400" dirty="0"/>
-              <a:t> for </a:t>
-            </a:r>
-            <a:r>
-              <a:rPr lang="en-US" sz="2400" dirty="0" err="1"/>
-              <a:t>homeworks</a:t>
-            </a:r>
-            <a:r>
+              <a:t>Exception: you can use them to help you writing tests. Keep in mind that you are have the end responsibility, so do check what AI recommends you.</a:t>
+            </a:r>
+            <a:br>
               <a:rPr lang="en-US" sz="2400" dirty="0"/>
-              <a:t> and proof assignments are </a:t>
-            </a:r>
-            <a:r>
-              <a:rPr lang="en-US" sz="2400" b="1" dirty="0">
-                <a:highlight>
-                  <a:srgbClr val="FFFF00"/>
-                </a:highlight>
-              </a:rPr>
-              <a:t>not allowed </a:t>
-            </a:r>
-            <a:r>
+            </a:br>
+            <a:br>
               <a:rPr lang="en-US" sz="2400" dirty="0"/>
-              <a:t>(count as cheating).</a:t>
-            </a:r>
-          </a:p>
-          <a:p>
+            </a:br>
             <a:r>
               <a:rPr lang="en-US" sz="2400" dirty="0"/>
-              <a:t>Using </a:t>
-            </a:r>
-            <a:r>
-              <a:rPr lang="en-US" sz="2400" dirty="0" err="1"/>
-              <a:t>CoPilot</a:t>
-            </a:r>
-            <a:r>
-              <a:rPr lang="en-US" sz="2400" dirty="0"/>
-              <a:t> for your testing project is allowed (we just see it as another test generator).</a:t>
-            </a:r>
-          </a:p>
-          <a:p>
-            <a:pPr lvl="1"/>
-            <a:r>
-              <a:rPr lang="en-US" sz="2400" dirty="0"/>
-              <a:t>Do not blindly trust </a:t>
-            </a:r>
-            <a:r>
-              <a:rPr lang="en-US" sz="2400" dirty="0" err="1"/>
-              <a:t>CoPilot</a:t>
-            </a:r>
-            <a:r>
-              <a:rPr lang="en-US" sz="2400" dirty="0"/>
-              <a:t> !</a:t>
-            </a:r>
-          </a:p>
-          <a:p>
-            <a:pPr lvl="1"/>
-            <a:r>
-              <a:rPr lang="en-US" sz="2400" dirty="0"/>
-              <a:t>You have the end-responsibility (you can’t blame </a:t>
-            </a:r>
-            <a:r>
-              <a:rPr lang="en-US" sz="2400" dirty="0" err="1"/>
-              <a:t>CoPilot</a:t>
-            </a:r>
-            <a:r>
-              <a:rPr lang="en-US" sz="2400" dirty="0"/>
-              <a:t> if your solution doesn’t work).</a:t>
-            </a:r>
-          </a:p>
-          <a:p>
-            <a:pPr lvl="1"/>
-            <a:endParaRPr lang="en-US" sz="2400" dirty="0"/>
+              <a:t>Your Rider IDE has support for copilot AI. </a:t>
+            </a:r>
           </a:p>
           <a:p>
             <a:pPr lvl="1"/>
@@ -5778,7 +5721,7 @@
           <a:p>
             <a:r>
               <a:rPr lang="en-US" sz="2400" dirty="0"/>
-              <a:t>Use </a:t>
+              <a:t>You can use </a:t>
             </a:r>
             <a:r>
               <a:rPr lang="en-US" sz="2400" dirty="0" err="1"/>
@@ -5786,7 +5729,15 @@
             </a:r>
             <a:r>
               <a:rPr lang="en-US" sz="2400" dirty="0"/>
-              <a:t> to host your project. </a:t>
+              <a:t> or </a:t>
+            </a:r>
+            <a:r>
+              <a:rPr lang="en-US" sz="2400" dirty="0" err="1"/>
+              <a:t>uu</a:t>
+            </a:r>
+            <a:r>
+              <a:rPr lang="en-US" sz="2400" dirty="0"/>
+              <a:t>-Gitlab to host your project. </a:t>
             </a:r>
             <a:r>
               <a:rPr lang="en-US" sz="2400" dirty="0">
@@ -6093,15 +6044,51 @@
           </a:p>
           <a:p>
             <a:r>
+              <a:rPr lang="en-NL" sz="2400" dirty="0">
+                <a:highlight>
+                  <a:srgbClr val="FFFF00"/>
+                </a:highlight>
+              </a:rPr>
+              <a:t>Brightspace</a:t>
+            </a:r>
+            <a:r>
               <a:rPr lang="en-NL" sz="2400" dirty="0"/>
-              <a:t>MS-Team B3STV, for:</a:t>
+              <a:t>, for</a:t>
             </a:r>
           </a:p>
           <a:p>
             <a:pPr lvl="1"/>
             <a:r>
               <a:rPr lang="en-NL" sz="2400" b="1" dirty="0"/>
-              <a:t>Submitting Testing-homeworks and Proof-assignments.</a:t>
+              <a:t>Testing Quizzes</a:t>
+            </a:r>
+          </a:p>
+          <a:p>
+            <a:pPr lvl="1"/>
+            <a:r>
+              <a:rPr lang="en-NL" sz="2400" b="1" dirty="0"/>
+              <a:t>Submitting project</a:t>
+            </a:r>
+          </a:p>
+          <a:p>
+            <a:r>
+              <a:rPr lang="en-NL" sz="2400" dirty="0">
+                <a:highlight>
+                  <a:srgbClr val="FFFF00"/>
+                </a:highlight>
+              </a:rPr>
+              <a:t>MS-Team B3STV</a:t>
+            </a:r>
+            <a:r>
+              <a:rPr lang="en-NL" sz="2400" dirty="0"/>
+              <a:t>, for:</a:t>
+            </a:r>
+          </a:p>
+          <a:p>
+            <a:pPr lvl="1"/>
+            <a:r>
+              <a:rPr lang="en-NL" sz="2400" b="1" dirty="0"/>
+              <a:t>Submitting formalization-assignments and Proof-assignments.</a:t>
             </a:r>
           </a:p>
           <a:p>
@@ -6114,7 +6101,7 @@
           <a:p>
             <a:r>
               <a:rPr lang="en-NL" sz="2400" dirty="0"/>
-              <a:t>Lectures and werkcolleges are physical (on-site) every Monday and Thursday. You have the T</a:t>
+              <a:t>Lectures and werkcolleges are physical (on-site) every Tuesday and Thursday. You have the T</a:t>
             </a:r>
             <a:r>
               <a:rPr lang="en-GB" sz="2400" dirty="0"/>
@@ -6226,7 +6213,7 @@
           <a:p>
             <a:r>
               <a:rPr lang="en-US" dirty="0"/>
-              <a:t>Crew</a:t>
+              <a:t>Team</a:t>
             </a:r>
           </a:p>
         </p:txBody>
@@ -6274,17 +6261,17 @@
           <a:p>
             <a:r>
               <a:rPr lang="en-US" sz="2800" dirty="0"/>
-              <a:t>Gabriele Keller (lectures)</a:t>
+              <a:t>Paige North (lectures)</a:t>
             </a:r>
           </a:p>
           <a:p>
             <a:r>
               <a:rPr lang="en-US" sz="2800" dirty="0"/>
-              <a:t>Quincy </a:t>
+              <a:t>Lana </a:t>
             </a:r>
             <a:r>
               <a:rPr lang="en-US" sz="2800" dirty="0" err="1"/>
-              <a:t>Einmahl</a:t>
+              <a:t>Idema</a:t>
             </a:r>
             <a:r>
               <a:rPr lang="en-US" sz="2800" dirty="0"/>
@@ -6297,12 +6284,8 @@
           </a:p>
           <a:p>
             <a:r>
-              <a:rPr lang="en-GB" sz="2800" dirty="0" err="1"/>
-              <a:t>Charl</a:t>
-            </a:r>
-            <a:r>
               <a:rPr lang="en-GB" sz="2800" dirty="0"/>
-              <a:t>-Pierre Marais </a:t>
+              <a:t>Justin Timmer </a:t>
             </a:r>
             <a:r>
               <a:rPr lang="en-NL" sz="2800" dirty="0"/>
@@ -6313,20 +6296,13 @@
           <a:p>
             <a:r>
               <a:rPr lang="en-NL" sz="2800" dirty="0"/>
-              <a:t>Ben Stokmans (TA, werkcollege)</a:t>
-            </a:r>
-          </a:p>
-          <a:p>
-            <a:r>
-              <a:rPr lang="en-GB" sz="2800" dirty="0"/>
-              <a:t>Mitchel Zhu </a:t>
-            </a:r>
-            <a:r>
-              <a:rPr lang="en-NL" sz="2800" dirty="0"/>
-              <a:t>(TA, werkcollege)</a:t>
-            </a:r>
-          </a:p>
-          <a:p>
+              <a:t>Tammo Steffens (TA, werkcollege)</a:t>
+            </a:r>
+          </a:p>
+          <a:p>
+            <a:pPr marL="0" indent="0">
+              <a:buNone/>
+            </a:pPr>
             <a:endParaRPr lang="en-NL" sz="2800" dirty="0"/>
           </a:p>
         </p:txBody>
@@ -6509,7 +6485,7 @@
             </a:pPr>
             <a:r>
               <a:rPr lang="en-US" sz="2800" dirty="0"/>
-              <a:t>Because poor quality, including software bugs, may have severe consequences</a:t>
+              <a:t>Because poor quality, including software bugs, may have real consequences</a:t>
             </a:r>
           </a:p>
           <a:p>
@@ -8215,24 +8191,53 @@
           <a:lstStyle/>
           <a:p>
             <a:r>
-              <a:rPr lang="en-US" sz="2800" dirty="0"/>
+              <a:rPr lang="en-US" sz="2400" dirty="0"/>
               <a:t> Project management aspects of quality assurance (QA) in a large project </a:t>
             </a:r>
-            <a:r>
-              <a:rPr lang="en-US" sz="2800" dirty="0">
+            <a:endParaRPr lang="en-US" sz="2400" dirty="0">
+              <a:sym typeface="Wingdings"/>
+            </a:endParaRPr>
+          </a:p>
+          <a:p>
+            <a:pPr lvl="1"/>
+            <a:r>
+              <a:rPr lang="en-US" sz="2000" dirty="0">
                 <a:sym typeface="Wingdings"/>
               </a:rPr>
-              <a:t> covered in Software Project (bachelor).</a:t>
-            </a:r>
-          </a:p>
-          <a:p>
-            <a:r>
-              <a:rPr lang="en-US" sz="2800" dirty="0">
+              <a:t>covered in Software Project (bachelor).</a:t>
+            </a:r>
+          </a:p>
+          <a:p>
+            <a:endParaRPr lang="en-US" sz="2400" dirty="0">
+              <a:sym typeface="Wingdings"/>
+            </a:endParaRPr>
+          </a:p>
+          <a:p>
+            <a:r>
+              <a:rPr lang="en-US" sz="2400" dirty="0">
                 <a:sym typeface="Wingdings"/>
               </a:rPr>
-              <a:t>Automated verification algorithms  covered in the Program Semantic &amp; Verification course (master).</a:t>
-            </a:r>
-            <a:endParaRPr lang="en-US" sz="2800" dirty="0"/>
+              <a:t>Automated verification algorithms </a:t>
+            </a:r>
+          </a:p>
+          <a:p>
+            <a:pPr lvl="1"/>
+            <a:r>
+              <a:rPr lang="en-US" sz="2000" dirty="0">
+                <a:sym typeface="Wingdings"/>
+              </a:rPr>
+              <a:t>covered in the Program Semantic &amp; Verification course (master).</a:t>
+            </a:r>
+          </a:p>
+          <a:p>
+            <a:pPr lvl="1"/>
+            <a:r>
+              <a:rPr lang="en-US" sz="2000" dirty="0">
+                <a:sym typeface="Wingdings"/>
+              </a:rPr>
+              <a:t>see also the “materials”-tab in the website: automated testing, theorem provers, proof assistants, CBMC (bounded model checker for C/C++).</a:t>
+            </a:r>
+            <a:endParaRPr lang="en-US" sz="2000" dirty="0"/>
           </a:p>
         </p:txBody>
       </p:sp>
@@ -8334,7 +8339,12 @@
             <p:ph idx="1"/>
           </p:nvPr>
         </p:nvSpPr>
-        <p:spPr/>
+        <p:spPr>
+          <a:xfrm>
+            <a:off x="457200" y="1600200"/>
+            <a:ext cx="8435280" cy="4525963"/>
+          </a:xfrm>
+        </p:spPr>
         <p:txBody>
           <a:bodyPr/>
           <a:lstStyle/>
@@ -8458,7 +8468,7 @@
           <a:p>
             <a:r>
               <a:rPr lang="en-US" dirty="0"/>
-              <a:t>Site &amp; Materials</a:t>
+              <a:t>Sites &amp; Materials</a:t>
             </a:r>
           </a:p>
         </p:txBody>
@@ -8475,8 +8485,8 @@
         </p:nvSpPr>
         <p:spPr>
           <a:xfrm>
-            <a:off x="457200" y="2060848"/>
-            <a:ext cx="8229600" cy="4065315"/>
+            <a:off x="457200" y="1417638"/>
+            <a:ext cx="8507288" cy="4708525"/>
           </a:xfrm>
         </p:spPr>
         <p:txBody>
@@ -8484,26 +8494,53 @@
           <a:lstStyle/>
           <a:p>
             <a:r>
+              <a:rPr lang="en-US" sz="2400" dirty="0">
+                <a:highlight>
+                  <a:srgbClr val="FFFF00"/>
+                </a:highlight>
+              </a:rPr>
+              <a:t>Website</a:t>
+            </a:r>
+            <a:r>
+              <a:rPr lang="en-US" sz="2400" dirty="0"/>
+              <a:t> is for now hosted in </a:t>
+            </a:r>
+            <a:r>
               <a:rPr lang="en-US" sz="2400" dirty="0" err="1"/>
-              <a:t>ics.uu.nl</a:t>
+              <a:t>github</a:t>
             </a:r>
             <a:r>
               <a:rPr lang="en-US" sz="2400" dirty="0"/>
-              <a:t>/docs/</a:t>
-            </a:r>
-            <a:r>
-              <a:rPr lang="en-US" sz="2400" dirty="0" err="1"/>
-              <a:t>vakken</a:t>
-            </a:r>
-            <a:r>
+              <a:t>:</a:t>
+            </a:r>
+            <a:br>
               <a:rPr lang="en-US" sz="2400" dirty="0"/>
-              <a:t>/b3stv</a:t>
-            </a:r>
-          </a:p>
-          <a:p>
+            </a:br>
+            <a:r>
+              <a:rPr lang="en-US" sz="2400" dirty="0">
+                <a:hlinkClick r:id="rId2"/>
+              </a:rPr>
+              <a:t>https://wooshrow.github.io/b3stv/</a:t>
+            </a:r>
+            <a:br>
+              <a:rPr lang="en-US" sz="2400" dirty="0"/>
+            </a:br>
+            <a:r>
+              <a:rPr lang="en-US" sz="2400" dirty="0">
+                <a:hlinkClick r:id="rId3"/>
+              </a:rPr>
+              <a:t>https://github.com/wooshrow/b3stv</a:t>
+            </a:r>
             <a:endParaRPr lang="en-US" sz="2400" dirty="0"/>
           </a:p>
           <a:p>
+            <a:r>
+              <a:rPr lang="en-US" sz="2400" dirty="0"/>
+              <a:t>Books:</a:t>
+            </a:r>
+          </a:p>
+          <a:p>
+            <a:pPr lvl="1"/>
             <a:r>
               <a:rPr lang="en-US" sz="2400" dirty="0"/>
               <a:t>Paul Ammann and Jeff Offutt, Introduction to Software Testing, </a:t>
@@ -8542,9 +8579,7 @@
             </a:r>
           </a:p>
           <a:p>
-            <a:endParaRPr lang="en-US" sz="2400" dirty="0"/>
-          </a:p>
-          <a:p>
+            <a:pPr lvl="1"/>
             <a:r>
               <a:rPr lang="en-US" sz="2400" dirty="0"/>
               <a:t>Lecture Notes (can be obtained from the website), for the program verification part.</a:t>

</xml_diff>